<commit_message>
v12: minimalist inclusion criteria - clean and simple design
</commit_message>
<xml_diff>
--- a/TFM_Presentacion_Denisa_Antoneac_v12.pptx
+++ b/TFM_Presentacion_Denisa_Antoneac_v12.pptx
@@ -14200,93 +14200,14 @@
       </p:sp>
       <p:sp>
         <p:nvSpPr>
-          <p:cNvPr id="6" name="Rectangle 5"/>
-          <p:cNvSpPr/>
+          <p:cNvPr id="6" name="TextBox 5"/>
+          <p:cNvSpPr txBox="1"/>
           <p:nvPr/>
         </p:nvSpPr>
         <p:spPr>
           <a:xfrm>
             <a:off x="800000" y="1650000"/>
-            <a:ext cx="10400000" cy="800000"/>
-          </a:xfrm>
-          <a:prstGeom prst="rect">
-            <a:avLst/>
-          </a:prstGeom>
-          <a:solidFill>
-            <a:srgbClr val="DFD8EC"/>
-          </a:solidFill>
-          <a:ln w="12700">
-            <a:solidFill>
-              <a:srgbClr val="2E2A3A"/>
-            </a:solidFill>
-          </a:ln>
-        </p:spPr>
-        <p:style>
-          <a:lnRef idx="1">
-            <a:schemeClr val="accent1"/>
-          </a:lnRef>
-          <a:fillRef idx="3">
-            <a:schemeClr val="accent1"/>
-          </a:fillRef>
-          <a:effectRef idx="2">
-            <a:schemeClr val="accent1"/>
-          </a:effectRef>
-          <a:fontRef idx="minor">
-            <a:schemeClr val="lt1"/>
-          </a:fontRef>
-        </p:style>
-        <p:txBody>
-          <a:bodyPr rtlCol="0" anchor="ctr"/>
-          <a:lstStyle/>
-          <a:p>
-            <a:pPr algn="ctr"/>
-          </a:p>
-        </p:txBody>
-      </p:sp>
-      <p:sp>
-        <p:nvSpPr>
-          <p:cNvPr id="7" name="TextBox 6"/>
-          <p:cNvSpPr txBox="1"/>
-          <p:nvPr/>
-        </p:nvSpPr>
-        <p:spPr>
-          <a:xfrm>
-            <a:off x="850000" y="1680000"/>
-            <a:ext cx="150000" cy="250000"/>
-          </a:xfrm>
-          <a:prstGeom prst="rect">
-            <a:avLst/>
-          </a:prstGeom>
-          <a:noFill/>
-        </p:spPr>
-        <p:txBody>
-          <a:bodyPr wrap="none">
-            <a:spAutoFit/>
-          </a:bodyPr>
-          <a:lstStyle/>
-          <a:p>
-            <a:pPr algn="ctr"/>
-            <a:r>
-              <a:rPr sz="2800" b="1">
-                <a:solidFill>
-                  <a:srgbClr val="9079C8"/>
-                </a:solidFill>
-              </a:rPr>
-              <a:t>(a)</a:t>
-            </a:r>
-          </a:p>
-        </p:txBody>
-      </p:sp>
-      <p:sp>
-        <p:nvSpPr>
-          <p:cNvPr id="8" name="TextBox 7"/>
-          <p:cNvSpPr txBox="1"/>
-          <p:nvPr/>
-        </p:nvSpPr>
-        <p:spPr>
-          <a:xfrm>
-            <a:off x="1050000" y="1700000"/>
-            <a:ext cx="10100000" cy="700000"/>
+            <a:ext cx="10400000" cy="570000"/>
           </a:xfrm>
           <a:prstGeom prst="rect">
             <a:avLst/>
@@ -14301,9 +14222,17 @@
           <a:p>
             <a:pPr algn="l"/>
             <a:r>
+              <a:rPr sz="1800" b="1">
+                <a:solidFill>
+                  <a:srgbClr val="9079C8"/>
+                </a:solidFill>
+              </a:rPr>
+              <a:t>(a) </a:t>
+            </a:r>
+            <a:r>
               <a:rPr sz="1600" b="0">
                 <a:solidFill>
-                  <a:srgbClr val="2E2A3A"/>
+                  <a:srgbClr val="4C4954"/>
                 </a:solidFill>
               </a:rPr>
               <a:t>Meta-análisis cuantitativo en revista científica con peer review</a:t>
@@ -14313,93 +14242,14 @@
       </p:sp>
       <p:sp>
         <p:nvSpPr>
-          <p:cNvPr id="9" name="Rectangle 8"/>
-          <p:cNvSpPr/>
-          <p:nvPr/>
-        </p:nvSpPr>
-        <p:spPr>
-          <a:xfrm>
-            <a:off x="800000" y="2550000"/>
-            <a:ext cx="10400000" cy="800000"/>
-          </a:xfrm>
-          <a:prstGeom prst="rect">
-            <a:avLst/>
-          </a:prstGeom>
-          <a:solidFill>
-            <a:srgbClr val="DFD8EC"/>
-          </a:solidFill>
-          <a:ln w="12700">
-            <a:solidFill>
-              <a:srgbClr val="2E2A3A"/>
-            </a:solidFill>
-          </a:ln>
-        </p:spPr>
-        <p:style>
-          <a:lnRef idx="1">
-            <a:schemeClr val="accent1"/>
-          </a:lnRef>
-          <a:fillRef idx="3">
-            <a:schemeClr val="accent1"/>
-          </a:fillRef>
-          <a:effectRef idx="2">
-            <a:schemeClr val="accent1"/>
-          </a:effectRef>
-          <a:fontRef idx="minor">
-            <a:schemeClr val="lt1"/>
-          </a:fontRef>
-        </p:style>
-        <p:txBody>
-          <a:bodyPr rtlCol="0" anchor="ctr"/>
-          <a:lstStyle/>
-          <a:p>
-            <a:pPr algn="ctr"/>
-          </a:p>
-        </p:txBody>
-      </p:sp>
-      <p:sp>
-        <p:nvSpPr>
-          <p:cNvPr id="10" name="TextBox 9"/>
-          <p:cNvSpPr txBox="1"/>
-          <p:nvPr/>
-        </p:nvSpPr>
-        <p:spPr>
-          <a:xfrm>
-            <a:off x="850000" y="2580000"/>
-            <a:ext cx="150000" cy="250000"/>
-          </a:xfrm>
-          <a:prstGeom prst="rect">
-            <a:avLst/>
-          </a:prstGeom>
-          <a:noFill/>
-        </p:spPr>
-        <p:txBody>
-          <a:bodyPr wrap="none">
-            <a:spAutoFit/>
-          </a:bodyPr>
-          <a:lstStyle/>
-          <a:p>
-            <a:pPr algn="ctr"/>
-            <a:r>
-              <a:rPr sz="2800" b="1">
-                <a:solidFill>
-                  <a:srgbClr val="9079C8"/>
-                </a:solidFill>
-              </a:rPr>
-              <a:t>(b)</a:t>
-            </a:r>
-          </a:p>
-        </p:txBody>
-      </p:sp>
-      <p:sp>
-        <p:nvSpPr>
-          <p:cNvPr id="11" name="TextBox 10"/>
-          <p:cNvSpPr txBox="1"/>
-          <p:nvPr/>
-        </p:nvSpPr>
-        <p:spPr>
-          <a:xfrm>
-            <a:off x="1050000" y="2600000"/>
-            <a:ext cx="10100000" cy="700000"/>
+          <p:cNvPr id="7" name="TextBox 6"/>
+          <p:cNvSpPr txBox="1"/>
+          <p:nvPr/>
+        </p:nvSpPr>
+        <p:spPr>
+          <a:xfrm>
+            <a:off x="800000" y="2270000"/>
+            <a:ext cx="10400000" cy="570000"/>
           </a:xfrm>
           <a:prstGeom prst="rect">
             <a:avLst/>
@@ -14414,9 +14264,17 @@
           <a:p>
             <a:pPr algn="l"/>
             <a:r>
+              <a:rPr sz="1800" b="1">
+                <a:solidFill>
+                  <a:srgbClr val="9079C8"/>
+                </a:solidFill>
+              </a:rPr>
+              <a:t>(b) </a:t>
+            </a:r>
+            <a:r>
               <a:rPr sz="1600" b="0">
                 <a:solidFill>
-                  <a:srgbClr val="2E2A3A"/>
+                  <a:srgbClr val="4C4954"/>
                 </a:solidFill>
               </a:rPr>
               <a:t>Autoestima o autoconcepto como variable principal</a:t>
@@ -14426,93 +14284,14 @@
       </p:sp>
       <p:sp>
         <p:nvSpPr>
-          <p:cNvPr id="12" name="Rectangle 11"/>
-          <p:cNvSpPr/>
-          <p:nvPr/>
-        </p:nvSpPr>
-        <p:spPr>
-          <a:xfrm>
-            <a:off x="800000" y="3450000"/>
-            <a:ext cx="10400000" cy="800000"/>
-          </a:xfrm>
-          <a:prstGeom prst="rect">
-            <a:avLst/>
-          </a:prstGeom>
-          <a:solidFill>
-            <a:srgbClr val="DFD8EC"/>
-          </a:solidFill>
-          <a:ln w="12700">
-            <a:solidFill>
-              <a:srgbClr val="2E2A3A"/>
-            </a:solidFill>
-          </a:ln>
-        </p:spPr>
-        <p:style>
-          <a:lnRef idx="1">
-            <a:schemeClr val="accent1"/>
-          </a:lnRef>
-          <a:fillRef idx="3">
-            <a:schemeClr val="accent1"/>
-          </a:fillRef>
-          <a:effectRef idx="2">
-            <a:schemeClr val="accent1"/>
-          </a:effectRef>
-          <a:fontRef idx="minor">
-            <a:schemeClr val="lt1"/>
-          </a:fontRef>
-        </p:style>
-        <p:txBody>
-          <a:bodyPr rtlCol="0" anchor="ctr"/>
-          <a:lstStyle/>
-          <a:p>
-            <a:pPr algn="ctr"/>
-          </a:p>
-        </p:txBody>
-      </p:sp>
-      <p:sp>
-        <p:nvSpPr>
-          <p:cNvPr id="13" name="TextBox 12"/>
-          <p:cNvSpPr txBox="1"/>
-          <p:nvPr/>
-        </p:nvSpPr>
-        <p:spPr>
-          <a:xfrm>
-            <a:off x="850000" y="3480000"/>
-            <a:ext cx="150000" cy="250000"/>
-          </a:xfrm>
-          <a:prstGeom prst="rect">
-            <a:avLst/>
-          </a:prstGeom>
-          <a:noFill/>
-        </p:spPr>
-        <p:txBody>
-          <a:bodyPr wrap="none">
-            <a:spAutoFit/>
-          </a:bodyPr>
-          <a:lstStyle/>
-          <a:p>
-            <a:pPr algn="ctr"/>
-            <a:r>
-              <a:rPr sz="2800" b="1">
-                <a:solidFill>
-                  <a:srgbClr val="9079C8"/>
-                </a:solidFill>
-              </a:rPr>
-              <a:t>(c)</a:t>
-            </a:r>
-          </a:p>
-        </p:txBody>
-      </p:sp>
-      <p:sp>
-        <p:nvSpPr>
-          <p:cNvPr id="14" name="TextBox 13"/>
-          <p:cNvSpPr txBox="1"/>
-          <p:nvPr/>
-        </p:nvSpPr>
-        <p:spPr>
-          <a:xfrm>
-            <a:off x="1050000" y="3500000"/>
-            <a:ext cx="10100000" cy="700000"/>
+          <p:cNvPr id="8" name="TextBox 7"/>
+          <p:cNvSpPr txBox="1"/>
+          <p:nvPr/>
+        </p:nvSpPr>
+        <p:spPr>
+          <a:xfrm>
+            <a:off x="800000" y="2890000"/>
+            <a:ext cx="10400000" cy="570000"/>
           </a:xfrm>
           <a:prstGeom prst="rect">
             <a:avLst/>
@@ -14527,9 +14306,17 @@
           <a:p>
             <a:pPr algn="l"/>
             <a:r>
+              <a:rPr sz="1800" b="1">
+                <a:solidFill>
+                  <a:srgbClr val="9079C8"/>
+                </a:solidFill>
+              </a:rPr>
+              <a:t>(c) </a:t>
+            </a:r>
+            <a:r>
               <a:rPr sz="1600" b="0">
                 <a:solidFill>
-                  <a:srgbClr val="2E2A3A"/>
+                  <a:srgbClr val="4C4954"/>
                 </a:solidFill>
               </a:rPr>
               <a:t>Indicador de bienestar adicional (subjetivo, psicológico, HRQoL o salud mental)</a:t>
@@ -14539,93 +14326,14 @@
       </p:sp>
       <p:sp>
         <p:nvSpPr>
-          <p:cNvPr id="15" name="Rectangle 14"/>
-          <p:cNvSpPr/>
-          <p:nvPr/>
-        </p:nvSpPr>
-        <p:spPr>
-          <a:xfrm>
-            <a:off x="800000" y="4350000"/>
-            <a:ext cx="10400000" cy="800000"/>
-          </a:xfrm>
-          <a:prstGeom prst="rect">
-            <a:avLst/>
-          </a:prstGeom>
-          <a:solidFill>
-            <a:srgbClr val="DFD8EC"/>
-          </a:solidFill>
-          <a:ln w="12700">
-            <a:solidFill>
-              <a:srgbClr val="2E2A3A"/>
-            </a:solidFill>
-          </a:ln>
-        </p:spPr>
-        <p:style>
-          <a:lnRef idx="1">
-            <a:schemeClr val="accent1"/>
-          </a:lnRef>
-          <a:fillRef idx="3">
-            <a:schemeClr val="accent1"/>
-          </a:fillRef>
-          <a:effectRef idx="2">
-            <a:schemeClr val="accent1"/>
-          </a:effectRef>
-          <a:fontRef idx="minor">
-            <a:schemeClr val="lt1"/>
-          </a:fontRef>
-        </p:style>
-        <p:txBody>
-          <a:bodyPr rtlCol="0" anchor="ctr"/>
-          <a:lstStyle/>
-          <a:p>
-            <a:pPr algn="ctr"/>
-          </a:p>
-        </p:txBody>
-      </p:sp>
-      <p:sp>
-        <p:nvSpPr>
-          <p:cNvPr id="16" name="TextBox 15"/>
-          <p:cNvSpPr txBox="1"/>
-          <p:nvPr/>
-        </p:nvSpPr>
-        <p:spPr>
-          <a:xfrm>
-            <a:off x="850000" y="4380000"/>
-            <a:ext cx="150000" cy="250000"/>
-          </a:xfrm>
-          <a:prstGeom prst="rect">
-            <a:avLst/>
-          </a:prstGeom>
-          <a:noFill/>
-        </p:spPr>
-        <p:txBody>
-          <a:bodyPr wrap="none">
-            <a:spAutoFit/>
-          </a:bodyPr>
-          <a:lstStyle/>
-          <a:p>
-            <a:pPr algn="ctr"/>
-            <a:r>
-              <a:rPr sz="2800" b="1">
-                <a:solidFill>
-                  <a:srgbClr val="9079C8"/>
-                </a:solidFill>
-              </a:rPr>
-              <a:t>(d)</a:t>
-            </a:r>
-          </a:p>
-        </p:txBody>
-      </p:sp>
-      <p:sp>
-        <p:nvSpPr>
-          <p:cNvPr id="17" name="TextBox 16"/>
-          <p:cNvSpPr txBox="1"/>
-          <p:nvPr/>
-        </p:nvSpPr>
-        <p:spPr>
-          <a:xfrm>
-            <a:off x="1050000" y="4400000"/>
-            <a:ext cx="10100000" cy="700000"/>
+          <p:cNvPr id="9" name="TextBox 8"/>
+          <p:cNvSpPr txBox="1"/>
+          <p:nvPr/>
+        </p:nvSpPr>
+        <p:spPr>
+          <a:xfrm>
+            <a:off x="800000" y="3510000"/>
+            <a:ext cx="10400000" cy="570000"/>
           </a:xfrm>
           <a:prstGeom prst="rect">
             <a:avLst/>
@@ -14640,9 +14348,17 @@
           <a:p>
             <a:pPr algn="l"/>
             <a:r>
+              <a:rPr sz="1800" b="1">
+                <a:solidFill>
+                  <a:srgbClr val="9079C8"/>
+                </a:solidFill>
+              </a:rPr>
+              <a:t>(d) </a:t>
+            </a:r>
+            <a:r>
               <a:rPr sz="1600" b="0">
                 <a:solidFill>
-                  <a:srgbClr val="2E2A3A"/>
+                  <a:srgbClr val="4C4954"/>
                 </a:solidFill>
               </a:rPr>
               <a:t>Población clínica/salud ≥75% (o análisis estratificados)</a:t>
@@ -14652,93 +14368,14 @@
       </p:sp>
       <p:sp>
         <p:nvSpPr>
-          <p:cNvPr id="18" name="Rectangle 17"/>
-          <p:cNvSpPr/>
-          <p:nvPr/>
-        </p:nvSpPr>
-        <p:spPr>
-          <a:xfrm>
-            <a:off x="800000" y="5250000"/>
-            <a:ext cx="10400000" cy="800000"/>
-          </a:xfrm>
-          <a:prstGeom prst="rect">
-            <a:avLst/>
-          </a:prstGeom>
-          <a:solidFill>
-            <a:srgbClr val="DFD8EC"/>
-          </a:solidFill>
-          <a:ln w="12700">
-            <a:solidFill>
-              <a:srgbClr val="2E2A3A"/>
-            </a:solidFill>
-          </a:ln>
-        </p:spPr>
-        <p:style>
-          <a:lnRef idx="1">
-            <a:schemeClr val="accent1"/>
-          </a:lnRef>
-          <a:fillRef idx="3">
-            <a:schemeClr val="accent1"/>
-          </a:fillRef>
-          <a:effectRef idx="2">
-            <a:schemeClr val="accent1"/>
-          </a:effectRef>
-          <a:fontRef idx="minor">
-            <a:schemeClr val="lt1"/>
-          </a:fontRef>
-        </p:style>
-        <p:txBody>
-          <a:bodyPr rtlCol="0" anchor="ctr"/>
-          <a:lstStyle/>
-          <a:p>
-            <a:pPr algn="ctr"/>
-          </a:p>
-        </p:txBody>
-      </p:sp>
-      <p:sp>
-        <p:nvSpPr>
-          <p:cNvPr id="19" name="TextBox 18"/>
-          <p:cNvSpPr txBox="1"/>
-          <p:nvPr/>
-        </p:nvSpPr>
-        <p:spPr>
-          <a:xfrm>
-            <a:off x="850000" y="5280000"/>
-            <a:ext cx="150000" cy="250000"/>
-          </a:xfrm>
-          <a:prstGeom prst="rect">
-            <a:avLst/>
-          </a:prstGeom>
-          <a:noFill/>
-        </p:spPr>
-        <p:txBody>
-          <a:bodyPr wrap="none">
-            <a:spAutoFit/>
-          </a:bodyPr>
-          <a:lstStyle/>
-          <a:p>
-            <a:pPr algn="ctr"/>
-            <a:r>
-              <a:rPr sz="2800" b="1">
-                <a:solidFill>
-                  <a:srgbClr val="9079C8"/>
-                </a:solidFill>
-              </a:rPr>
-              <a:t>(e)</a:t>
-            </a:r>
-          </a:p>
-        </p:txBody>
-      </p:sp>
-      <p:sp>
-        <p:nvSpPr>
-          <p:cNvPr id="20" name="TextBox 19"/>
-          <p:cNvSpPr txBox="1"/>
-          <p:nvPr/>
-        </p:nvSpPr>
-        <p:spPr>
-          <a:xfrm>
-            <a:off x="1050000" y="5300000"/>
-            <a:ext cx="10100000" cy="700000"/>
+          <p:cNvPr id="10" name="TextBox 9"/>
+          <p:cNvSpPr txBox="1"/>
+          <p:nvPr/>
+        </p:nvSpPr>
+        <p:spPr>
+          <a:xfrm>
+            <a:off x="800000" y="4130000"/>
+            <a:ext cx="10400000" cy="570000"/>
           </a:xfrm>
           <a:prstGeom prst="rect">
             <a:avLst/>
@@ -14753,9 +14390,17 @@
           <a:p>
             <a:pPr algn="l"/>
             <a:r>
+              <a:rPr sz="1800" b="1">
+                <a:solidFill>
+                  <a:srgbClr val="9079C8"/>
+                </a:solidFill>
+              </a:rPr>
+              <a:t>(e) </a:t>
+            </a:r>
+            <a:r>
               <a:rPr sz="1600" b="0">
                 <a:solidFill>
-                  <a:srgbClr val="2E2A3A"/>
+                  <a:srgbClr val="4C4954"/>
                 </a:solidFill>
               </a:rPr>
               <a:t>Publicado en inglés o español</a:t>
@@ -14765,93 +14410,14 @@
       </p:sp>
       <p:sp>
         <p:nvSpPr>
-          <p:cNvPr id="21" name="Rectangle 20"/>
-          <p:cNvSpPr/>
-          <p:nvPr/>
-        </p:nvSpPr>
-        <p:spPr>
-          <a:xfrm>
-            <a:off x="800000" y="6150000"/>
-            <a:ext cx="10400000" cy="800000"/>
-          </a:xfrm>
-          <a:prstGeom prst="rect">
-            <a:avLst/>
-          </a:prstGeom>
-          <a:solidFill>
-            <a:srgbClr val="DFD8EC"/>
-          </a:solidFill>
-          <a:ln w="12700">
-            <a:solidFill>
-              <a:srgbClr val="2E2A3A"/>
-            </a:solidFill>
-          </a:ln>
-        </p:spPr>
-        <p:style>
-          <a:lnRef idx="1">
-            <a:schemeClr val="accent1"/>
-          </a:lnRef>
-          <a:fillRef idx="3">
-            <a:schemeClr val="accent1"/>
-          </a:fillRef>
-          <a:effectRef idx="2">
-            <a:schemeClr val="accent1"/>
-          </a:effectRef>
-          <a:fontRef idx="minor">
-            <a:schemeClr val="lt1"/>
-          </a:fontRef>
-        </p:style>
-        <p:txBody>
-          <a:bodyPr rtlCol="0" anchor="ctr"/>
-          <a:lstStyle/>
-          <a:p>
-            <a:pPr algn="ctr"/>
-          </a:p>
-        </p:txBody>
-      </p:sp>
-      <p:sp>
-        <p:nvSpPr>
-          <p:cNvPr id="22" name="TextBox 21"/>
-          <p:cNvSpPr txBox="1"/>
-          <p:nvPr/>
-        </p:nvSpPr>
-        <p:spPr>
-          <a:xfrm>
-            <a:off x="850000" y="6180000"/>
-            <a:ext cx="150000" cy="250000"/>
-          </a:xfrm>
-          <a:prstGeom prst="rect">
-            <a:avLst/>
-          </a:prstGeom>
-          <a:noFill/>
-        </p:spPr>
-        <p:txBody>
-          <a:bodyPr wrap="none">
-            <a:spAutoFit/>
-          </a:bodyPr>
-          <a:lstStyle/>
-          <a:p>
-            <a:pPr algn="ctr"/>
-            <a:r>
-              <a:rPr sz="2800" b="1">
-                <a:solidFill>
-                  <a:srgbClr val="9079C8"/>
-                </a:solidFill>
-              </a:rPr>
-              <a:t>(f)</a:t>
-            </a:r>
-          </a:p>
-        </p:txBody>
-      </p:sp>
-      <p:sp>
-        <p:nvSpPr>
-          <p:cNvPr id="23" name="TextBox 22"/>
-          <p:cNvSpPr txBox="1"/>
-          <p:nvPr/>
-        </p:nvSpPr>
-        <p:spPr>
-          <a:xfrm>
-            <a:off x="1050000" y="6200000"/>
-            <a:ext cx="10100000" cy="700000"/>
+          <p:cNvPr id="11" name="TextBox 10"/>
+          <p:cNvSpPr txBox="1"/>
+          <p:nvPr/>
+        </p:nvSpPr>
+        <p:spPr>
+          <a:xfrm>
+            <a:off x="800000" y="4750000"/>
+            <a:ext cx="10400000" cy="570000"/>
           </a:xfrm>
           <a:prstGeom prst="rect">
             <a:avLst/>
@@ -14866,9 +14432,17 @@
           <a:p>
             <a:pPr algn="l"/>
             <a:r>
+              <a:rPr sz="1800" b="1">
+                <a:solidFill>
+                  <a:srgbClr val="9079C8"/>
+                </a:solidFill>
+              </a:rPr>
+              <a:t>(f) </a:t>
+            </a:r>
+            <a:r>
               <a:rPr sz="1600" b="0">
                 <a:solidFill>
-                  <a:srgbClr val="2E2A3A"/>
+                  <a:srgbClr val="4C4954"/>
                 </a:solidFill>
               </a:rPr>
               <a:t>Publicado entre 1 enero 2016 y 25 mayo 2026</a:t>
@@ -14878,7 +14452,7 @@
       </p:sp>
       <p:sp>
         <p:nvSpPr>
-          <p:cNvPr id="24" name="TextBox 23"/>
+          <p:cNvPr id="12" name="TextBox 11"/>
           <p:cNvSpPr txBox="1"/>
           <p:nvPr/>
         </p:nvSpPr>
@@ -14912,7 +14486,7 @@
       </p:sp>
       <p:sp>
         <p:nvSpPr>
-          <p:cNvPr id="25" name="Oval 24"/>
+          <p:cNvPr id="13" name="Oval 12"/>
           <p:cNvSpPr/>
           <p:nvPr/>
         </p:nvSpPr>
@@ -14955,7 +14529,7 @@
       </p:sp>
       <p:sp>
         <p:nvSpPr>
-          <p:cNvPr id="26" name="TextBox 25"/>
+          <p:cNvPr id="14" name="TextBox 13"/>
           <p:cNvSpPr txBox="1"/>
           <p:nvPr/>
         </p:nvSpPr>

</xml_diff>